<commit_message>
Fix: yangi Stil_gamma1 shablon; max_tokens oshirildi (10sl=6000); JSON truncate retry; SVG ikonkalar olib tashlandi
</commit_message>
<xml_diff>
--- a/templates/shablonlar/platinum.pptx
+++ b/templates/shablonlar/platinum.pptx
@@ -1145,7 +1145,7 @@
           <a:p>
             <a:fld id="{710AE426-CBD1-49BA-A1DA-945CCEE2ED80}" type="datetimeFigureOut">
               <a:rPr lang="en-US" smtClean="0"/>
-              <a:t>8/1/2026</a:t>
+              <a:t>8/5/2026</a:t>
             </a:fld>
             <a:endParaRPr lang="en-US"/>
           </a:p>
@@ -1489,7 +1489,7 @@
           <a:p>
             <a:fld id="{710AE426-CBD1-49BA-A1DA-945CCEE2ED80}" type="datetimeFigureOut">
               <a:rPr lang="en-US" smtClean="0"/>
-              <a:t>8/1/2026</a:t>
+              <a:t>8/5/2026</a:t>
             </a:fld>
             <a:endParaRPr lang="en-US"/>
           </a:p>
@@ -1769,7 +1769,7 @@
           <a:p>
             <a:fld id="{710AE426-CBD1-49BA-A1DA-945CCEE2ED80}" type="datetimeFigureOut">
               <a:rPr lang="en-US" smtClean="0"/>
-              <a:t>8/1/2026</a:t>
+              <a:t>8/5/2026</a:t>
             </a:fld>
             <a:endParaRPr lang="en-US"/>
           </a:p>
@@ -2002,7 +2002,7 @@
           <a:p>
             <a:fld id="{710AE426-CBD1-49BA-A1DA-945CCEE2ED80}" type="datetimeFigureOut">
               <a:rPr lang="en-US" smtClean="0"/>
-              <a:t>8/1/2026</a:t>
+              <a:t>8/5/2026</a:t>
             </a:fld>
             <a:endParaRPr lang="en-US"/>
           </a:p>
@@ -2291,7 +2291,7 @@
           <a:p>
             <a:fld id="{710AE426-CBD1-49BA-A1DA-945CCEE2ED80}" type="datetimeFigureOut">
               <a:rPr lang="en-US" smtClean="0"/>
-              <a:t>8/1/2026</a:t>
+              <a:t>8/5/2026</a:t>
             </a:fld>
             <a:endParaRPr lang="en-US"/>
           </a:p>
@@ -2580,7 +2580,7 @@
           <a:p>
             <a:fld id="{710AE426-CBD1-49BA-A1DA-945CCEE2ED80}" type="datetimeFigureOut">
               <a:rPr lang="en-US" smtClean="0"/>
-              <a:t>8/1/2026</a:t>
+              <a:t>8/5/2026</a:t>
             </a:fld>
             <a:endParaRPr lang="en-US"/>
           </a:p>
@@ -2987,7 +2987,7 @@
           <a:p>
             <a:fld id="{710AE426-CBD1-49BA-A1DA-945CCEE2ED80}" type="datetimeFigureOut">
               <a:rPr lang="en-US" smtClean="0"/>
-              <a:t>8/1/2026</a:t>
+              <a:t>8/5/2026</a:t>
             </a:fld>
             <a:endParaRPr lang="en-US"/>
           </a:p>
@@ -3280,7 +3280,7 @@
           <a:p>
             <a:fld id="{710AE426-CBD1-49BA-A1DA-945CCEE2ED80}" type="datetimeFigureOut">
               <a:rPr lang="en-US" smtClean="0"/>
-              <a:t>8/1/2026</a:t>
+              <a:t>8/5/2026</a:t>
             </a:fld>
             <a:endParaRPr lang="en-US"/>
           </a:p>
@@ -3554,7 +3554,7 @@
           <a:p>
             <a:fld id="{710AE426-CBD1-49BA-A1DA-945CCEE2ED80}" type="datetimeFigureOut">
               <a:rPr lang="en-US" smtClean="0"/>
-              <a:t>8/1/2026</a:t>
+              <a:t>8/5/2026</a:t>
             </a:fld>
             <a:endParaRPr lang="en-US"/>
           </a:p>
@@ -3824,7 +3824,7 @@
           <a:p>
             <a:fld id="{710AE426-CBD1-49BA-A1DA-945CCEE2ED80}" type="datetimeFigureOut">
               <a:rPr lang="en-US" smtClean="0"/>
-              <a:t>8/1/2026</a:t>
+              <a:t>8/5/2026</a:t>
             </a:fld>
             <a:endParaRPr lang="en-US"/>
           </a:p>
@@ -4056,7 +4056,7 @@
           <a:p>
             <a:fld id="{710AE426-CBD1-49BA-A1DA-945CCEE2ED80}" type="datetimeFigureOut">
               <a:rPr lang="en-US" smtClean="0"/>
-              <a:t>8/1/2026</a:t>
+              <a:t>8/5/2026</a:t>
             </a:fld>
             <a:endParaRPr lang="en-US"/>
           </a:p>
@@ -4277,7 +4277,7 @@
           <a:p>
             <a:fld id="{710AE426-CBD1-49BA-A1DA-945CCEE2ED80}" type="datetimeFigureOut">
               <a:rPr lang="en-US" smtClean="0"/>
-              <a:t>8/1/2026</a:t>
+              <a:t>8/5/2026</a:t>
             </a:fld>
             <a:endParaRPr lang="en-US"/>
           </a:p>
@@ -4530,7 +4530,7 @@
           <a:p>
             <a:fld id="{710AE426-CBD1-49BA-A1DA-945CCEE2ED80}" type="datetimeFigureOut">
               <a:rPr lang="en-US" smtClean="0"/>
-              <a:t>8/1/2026</a:t>
+              <a:t>8/5/2026</a:t>
             </a:fld>
             <a:endParaRPr lang="en-US"/>
           </a:p>
@@ -4742,7 +4742,7 @@
           <a:p>
             <a:fld id="{710AE426-CBD1-49BA-A1DA-945CCEE2ED80}" type="datetimeFigureOut">
               <a:rPr lang="en-US" smtClean="0"/>
-              <a:t>8/1/2026</a:t>
+              <a:t>8/5/2026</a:t>
             </a:fld>
             <a:endParaRPr lang="en-US"/>
           </a:p>
@@ -5023,7 +5023,7 @@
           <a:p>
             <a:fld id="{710AE426-CBD1-49BA-A1DA-945CCEE2ED80}" type="datetimeFigureOut">
               <a:rPr lang="en-US" smtClean="0"/>
-              <a:t>8/1/2026</a:t>
+              <a:t>8/5/2026</a:t>
             </a:fld>
             <a:endParaRPr lang="en-US"/>
           </a:p>
@@ -5456,7 +5456,7 @@
           <a:p>
             <a:fld id="{710AE426-CBD1-49BA-A1DA-945CCEE2ED80}" type="datetimeFigureOut">
               <a:rPr lang="en-US" smtClean="0"/>
-              <a:t>8/1/2026</a:t>
+              <a:t>8/5/2026</a:t>
             </a:fld>
             <a:endParaRPr lang="en-US"/>
           </a:p>
@@ -5611,7 +5611,7 @@
           <a:p>
             <a:fld id="{710AE426-CBD1-49BA-A1DA-945CCEE2ED80}" type="datetimeFigureOut">
               <a:rPr lang="en-US" smtClean="0"/>
-              <a:t>8/1/2026</a:t>
+              <a:t>8/5/2026</a:t>
             </a:fld>
             <a:endParaRPr lang="en-US"/>
           </a:p>
@@ -5725,7 +5725,7 @@
           <a:p>
             <a:fld id="{710AE426-CBD1-49BA-A1DA-945CCEE2ED80}" type="datetimeFigureOut">
               <a:rPr lang="en-US" smtClean="0"/>
-              <a:t>8/1/2026</a:t>
+              <a:t>8/5/2026</a:t>
             </a:fld>
             <a:endParaRPr lang="en-US"/>
           </a:p>
@@ -5968,7 +5968,7 @@
           <a:p>
             <a:fld id="{710AE426-CBD1-49BA-A1DA-945CCEE2ED80}" type="datetimeFigureOut">
               <a:rPr lang="en-US" smtClean="0"/>
-              <a:t>8/1/2026</a:t>
+              <a:t>8/5/2026</a:t>
             </a:fld>
             <a:endParaRPr lang="en-US"/>
           </a:p>
@@ -6213,7 +6213,7 @@
           <a:p>
             <a:fld id="{710AE426-CBD1-49BA-A1DA-945CCEE2ED80}" type="datetimeFigureOut">
               <a:rPr lang="en-US" smtClean="0"/>
-              <a:t>8/1/2026</a:t>
+              <a:t>8/5/2026</a:t>
             </a:fld>
             <a:endParaRPr lang="en-US"/>
           </a:p>
@@ -6554,7 +6554,7 @@
           <a:p>
             <a:fld id="{710AE426-CBD1-49BA-A1DA-945CCEE2ED80}" type="datetimeFigureOut">
               <a:rPr lang="en-US" smtClean="0"/>
-              <a:t>8/1/2026</a:t>
+              <a:t>8/5/2026</a:t>
             </a:fld>
             <a:endParaRPr lang="en-US"/>
           </a:p>
@@ -6782,7 +6782,7 @@
           <a:p>
             <a:fld id="{710AE426-CBD1-49BA-A1DA-945CCEE2ED80}" type="datetimeFigureOut">
               <a:rPr lang="en-US" smtClean="0"/>
-              <a:t>8/1/2026</a:t>
+              <a:t>8/5/2026</a:t>
             </a:fld>
             <a:endParaRPr lang="en-US"/>
           </a:p>
@@ -6967,7 +6967,7 @@
           <a:p>
             <a:fld id="{710AE426-CBD1-49BA-A1DA-945CCEE2ED80}" type="datetimeFigureOut">
               <a:rPr lang="en-US" smtClean="0"/>
-              <a:t>8/1/2026</a:t>
+              <a:t>8/5/2026</a:t>
             </a:fld>
             <a:endParaRPr lang="en-US"/>
           </a:p>
@@ -7232,7 +7232,7 @@
           <a:p>
             <a:fld id="{710AE426-CBD1-49BA-A1DA-945CCEE2ED80}" type="datetimeFigureOut">
               <a:rPr lang="en-US" smtClean="0"/>
-              <a:t>8/1/2026</a:t>
+              <a:t>8/5/2026</a:t>
             </a:fld>
             <a:endParaRPr lang="en-US"/>
           </a:p>
@@ -7581,7 +7581,7 @@
           <a:p>
             <a:fld id="{710AE426-CBD1-49BA-A1DA-945CCEE2ED80}" type="datetimeFigureOut">
               <a:rPr lang="en-US" smtClean="0"/>
-              <a:t>8/1/2026</a:t>
+              <a:t>8/5/2026</a:t>
             </a:fld>
             <a:endParaRPr lang="en-US"/>
           </a:p>
@@ -7804,7 +7804,7 @@
           <a:p>
             <a:fld id="{710AE426-CBD1-49BA-A1DA-945CCEE2ED80}" type="datetimeFigureOut">
               <a:rPr lang="en-US" smtClean="0"/>
-              <a:t>8/1/2026</a:t>
+              <a:t>8/5/2026</a:t>
             </a:fld>
             <a:endParaRPr lang="en-US"/>
           </a:p>
@@ -8022,7 +8022,7 @@
           <a:p>
             <a:fld id="{710AE426-CBD1-49BA-A1DA-945CCEE2ED80}" type="datetimeFigureOut">
               <a:rPr lang="en-US" smtClean="0"/>
-              <a:t>8/1/2026</a:t>
+              <a:t>8/5/2026</a:t>
             </a:fld>
             <a:endParaRPr lang="en-US"/>
           </a:p>
@@ -8280,7 +8280,7 @@
           <a:p>
             <a:fld id="{710AE426-CBD1-49BA-A1DA-945CCEE2ED80}" type="datetimeFigureOut">
               <a:rPr lang="en-US" smtClean="0"/>
-              <a:t>8/1/2026</a:t>
+              <a:t>8/5/2026</a:t>
             </a:fld>
             <a:endParaRPr lang="en-US"/>
           </a:p>
@@ -11012,9 +11012,15 @@
   <p:cSld name="Slide 5">
     <p:bg>
       <p:bgPr>
-        <a:solidFill>
-          <a:srgbClr val="FAFFFA"/>
-        </a:solidFill>
+        <a:blipFill dpi="0" rotWithShape="1">
+          <a:blip r:embed="rId3">
+            <a:lum/>
+          </a:blip>
+          <a:srcRect/>
+          <a:stretch>
+            <a:fillRect/>
+          </a:stretch>
+        </a:blipFill>
         <a:effectLst/>
       </p:bgPr>
     </p:bg>
@@ -11076,36 +11082,6 @@
           </a:p>
         </p:txBody>
       </p:sp>
-      <p:pic>
-        <p:nvPicPr>
-          <p:cNvPr id="4" name="Image 0" descr="preencoded.png"/>
-          <p:cNvPicPr>
-            <a:picLocks noChangeAspect="1"/>
-          </p:cNvPicPr>
-          <p:nvPr/>
-        </p:nvPicPr>
-        <p:blipFill>
-          <a:blip>
-            <a:extLst>
-              <a:ext uri="{96DAC541-7B7A-43D3-8B79-37D633B846F1}">
-                <asvg:svgBlip xmlns:asvg="http://schemas.microsoft.com/office/drawing/2016/SVG/main" r:embed="rId3"/>
-              </a:ext>
-            </a:extLst>
-          </a:blip>
-          <a:stretch>
-            <a:fillRect/>
-          </a:stretch>
-        </p:blipFill>
-        <p:spPr>
-          <a:xfrm>
-            <a:off x="496119" y="2127870"/>
-            <a:ext cx="425276" cy="425276"/>
-          </a:xfrm>
-          <a:prstGeom prst="rect">
-            <a:avLst/>
-          </a:prstGeom>
-        </p:spPr>
-      </p:pic>
       <p:sp>
         <p:nvSpPr>
           <p:cNvPr id="5" name="Text 2"/>
@@ -11194,36 +11170,6 @@
           </a:p>
         </p:txBody>
       </p:sp>
-      <p:pic>
-        <p:nvPicPr>
-          <p:cNvPr id="7" name="Image 1" descr="preencoded.png"/>
-          <p:cNvPicPr>
-            <a:picLocks noChangeAspect="1"/>
-          </p:cNvPicPr>
-          <p:nvPr/>
-        </p:nvPicPr>
-        <p:blipFill>
-          <a:blip>
-            <a:extLst>
-              <a:ext uri="{96DAC541-7B7A-43D3-8B79-37D633B846F1}">
-                <asvg:svgBlip xmlns:asvg="http://schemas.microsoft.com/office/drawing/2016/SVG/main" r:embed="rId4"/>
-              </a:ext>
-            </a:extLst>
-          </a:blip>
-          <a:stretch>
-            <a:fillRect/>
-          </a:stretch>
-        </p:blipFill>
-        <p:spPr>
-          <a:xfrm>
-            <a:off x="3272433" y="2127870"/>
-            <a:ext cx="425276" cy="425276"/>
-          </a:xfrm>
-          <a:prstGeom prst="rect">
-            <a:avLst/>
-          </a:prstGeom>
-        </p:spPr>
-      </p:pic>
       <p:sp>
         <p:nvSpPr>
           <p:cNvPr id="8" name="Text 4"/>
@@ -11310,36 +11256,6 @@
           </a:p>
         </p:txBody>
       </p:sp>
-      <p:pic>
-        <p:nvPicPr>
-          <p:cNvPr id="10" name="Image 2" descr="preencoded.png"/>
-          <p:cNvPicPr>
-            <a:picLocks noChangeAspect="1"/>
-          </p:cNvPicPr>
-          <p:nvPr/>
-        </p:nvPicPr>
-        <p:blipFill>
-          <a:blip>
-            <a:extLst>
-              <a:ext uri="{96DAC541-7B7A-43D3-8B79-37D633B846F1}">
-                <asvg:svgBlip xmlns:asvg="http://schemas.microsoft.com/office/drawing/2016/SVG/main" r:embed="rId5"/>
-              </a:ext>
-            </a:extLst>
-          </a:blip>
-          <a:stretch>
-            <a:fillRect/>
-          </a:stretch>
-        </p:blipFill>
-        <p:spPr>
-          <a:xfrm>
-            <a:off x="6048747" y="2127870"/>
-            <a:ext cx="425276" cy="425276"/>
-          </a:xfrm>
-          <a:prstGeom prst="rect">
-            <a:avLst/>
-          </a:prstGeom>
-        </p:spPr>
-      </p:pic>
       <p:sp>
         <p:nvSpPr>
           <p:cNvPr id="11" name="Text 6"/>
@@ -11439,9 +11355,15 @@
   <p:cSld name="Slide 6">
     <p:bg>
       <p:bgPr>
-        <a:solidFill>
-          <a:srgbClr val="FAFFFA"/>
-        </a:solidFill>
+        <a:blipFill dpi="0" rotWithShape="1">
+          <a:blip r:embed="rId3">
+            <a:lum/>
+          </a:blip>
+          <a:srcRect/>
+          <a:stretch>
+            <a:fillRect/>
+          </a:stretch>
+        </a:blipFill>
         <a:effectLst/>
       </p:bgPr>
     </p:bg>
@@ -11468,7 +11390,7 @@
           <p:nvPr/>
         </p:nvPicPr>
         <p:blipFill>
-          <a:blip r:embed="rId3"/>
+          <a:blip r:embed="rId4"/>
           <a:stretch>
             <a:fillRect/>
           </a:stretch>
@@ -11527,36 +11449,6 @@
           </a:p>
         </p:txBody>
       </p:sp>
-      <p:pic>
-        <p:nvPicPr>
-          <p:cNvPr id="5" name="Image 1" descr="preencoded.png"/>
-          <p:cNvPicPr>
-            <a:picLocks noChangeAspect="1"/>
-          </p:cNvPicPr>
-          <p:nvPr/>
-        </p:nvPicPr>
-        <p:blipFill>
-          <a:blip>
-            <a:extLst>
-              <a:ext uri="{96DAC541-7B7A-43D3-8B79-37D633B846F1}">
-                <asvg:svgBlip xmlns:asvg="http://schemas.microsoft.com/office/drawing/2016/SVG/main" r:embed="rId4"/>
-              </a:ext>
-            </a:extLst>
-          </a:blip>
-          <a:stretch>
-            <a:fillRect/>
-          </a:stretch>
-        </p:blipFill>
-        <p:spPr>
-          <a:xfrm>
-            <a:off x="3925119" y="1936403"/>
-            <a:ext cx="4722763" cy="848320"/>
-          </a:xfrm>
-          <a:prstGeom prst="rect">
-            <a:avLst/>
-          </a:prstGeom>
-        </p:spPr>
-      </p:pic>
       <p:sp>
         <p:nvSpPr>
           <p:cNvPr id="6" name="Text 2"/>
@@ -11643,36 +11535,6 @@
           </a:p>
         </p:txBody>
       </p:sp>
-      <p:pic>
-        <p:nvPicPr>
-          <p:cNvPr id="8" name="Image 2" descr="preencoded.png"/>
-          <p:cNvPicPr>
-            <a:picLocks noChangeAspect="1"/>
-          </p:cNvPicPr>
-          <p:nvPr/>
-        </p:nvPicPr>
-        <p:blipFill>
-          <a:blip>
-            <a:extLst>
-              <a:ext uri="{96DAC541-7B7A-43D3-8B79-37D633B846F1}">
-                <asvg:svgBlip xmlns:asvg="http://schemas.microsoft.com/office/drawing/2016/SVG/main" r:embed="rId4"/>
-              </a:ext>
-            </a:extLst>
-          </a:blip>
-          <a:stretch>
-            <a:fillRect/>
-          </a:stretch>
-        </p:blipFill>
-        <p:spPr>
-          <a:xfrm>
-            <a:off x="3925119" y="2881908"/>
-            <a:ext cx="4722763" cy="848320"/>
-          </a:xfrm>
-          <a:prstGeom prst="rect">
-            <a:avLst/>
-          </a:prstGeom>
-        </p:spPr>
-      </p:pic>
       <p:sp>
         <p:nvSpPr>
           <p:cNvPr id="9" name="Text 4"/>
@@ -11759,36 +11621,6 @@
           </a:p>
         </p:txBody>
       </p:sp>
-      <p:pic>
-        <p:nvPicPr>
-          <p:cNvPr id="11" name="Image 3" descr="preencoded.png"/>
-          <p:cNvPicPr>
-            <a:picLocks noChangeAspect="1"/>
-          </p:cNvPicPr>
-          <p:nvPr/>
-        </p:nvPicPr>
-        <p:blipFill>
-          <a:blip>
-            <a:extLst>
-              <a:ext uri="{96DAC541-7B7A-43D3-8B79-37D633B846F1}">
-                <asvg:svgBlip xmlns:asvg="http://schemas.microsoft.com/office/drawing/2016/SVG/main" r:embed="rId4"/>
-              </a:ext>
-            </a:extLst>
-          </a:blip>
-          <a:stretch>
-            <a:fillRect/>
-          </a:stretch>
-        </p:blipFill>
-        <p:spPr>
-          <a:xfrm>
-            <a:off x="3925119" y="3827413"/>
-            <a:ext cx="4722763" cy="848320"/>
-          </a:xfrm>
-          <a:prstGeom prst="rect">
-            <a:avLst/>
-          </a:prstGeom>
-        </p:spPr>
-      </p:pic>
       <p:sp>
         <p:nvSpPr>
           <p:cNvPr id="12" name="Text 6"/>
@@ -11888,9 +11720,15 @@
   <p:cSld name="Slide 9">
     <p:bg>
       <p:bgPr>
-        <a:solidFill>
-          <a:srgbClr val="FAFFFA"/>
-        </a:solidFill>
+        <a:blipFill dpi="0" rotWithShape="1">
+          <a:blip r:embed="rId3">
+            <a:lum/>
+          </a:blip>
+          <a:srcRect/>
+          <a:stretch>
+            <a:fillRect/>
+          </a:stretch>
+        </a:blipFill>
         <a:effectLst/>
       </p:bgPr>
     </p:bg>
@@ -11952,63 +11790,6 @@
           </a:p>
         </p:txBody>
       </p:sp>
-      <p:pic>
-        <p:nvPicPr>
-          <p:cNvPr id="3" name="Image 0" descr="preencoded.png"/>
-          <p:cNvPicPr>
-            <a:picLocks noChangeAspect="1"/>
-          </p:cNvPicPr>
-          <p:nvPr/>
-        </p:nvPicPr>
-        <p:blipFill>
-          <a:blip>
-            <a:extLst>
-              <a:ext uri="{96DAC541-7B7A-43D3-8B79-37D633B846F1}">
-                <asvg:svgBlip xmlns:asvg="http://schemas.microsoft.com/office/drawing/2016/SVG/main" r:embed="rId3"/>
-              </a:ext>
-            </a:extLst>
-          </a:blip>
-          <a:stretch>
-            <a:fillRect/>
-          </a:stretch>
-        </p:blipFill>
-        <p:spPr>
-          <a:xfrm>
-            <a:off x="496119" y="1906042"/>
-            <a:ext cx="141759" cy="141759"/>
-          </a:xfrm>
-          <a:prstGeom prst="rect">
-            <a:avLst/>
-          </a:prstGeom>
-        </p:spPr>
-      </p:pic>
-      <p:sp>
-        <p:nvSpPr>
-          <p:cNvPr id="4" name="Shape 1"/>
-          <p:cNvSpPr/>
-          <p:nvPr/>
-        </p:nvSpPr>
-        <p:spPr>
-          <a:xfrm>
-            <a:off x="496119" y="2110234"/>
-            <a:ext cx="4004965" cy="19050"/>
-          </a:xfrm>
-          <a:prstGeom prst="rect">
-            <a:avLst/>
-          </a:prstGeom>
-          <a:solidFill>
-            <a:srgbClr val="438951"/>
-          </a:solidFill>
-          <a:ln/>
-        </p:spPr>
-        <p:txBody>
-          <a:bodyPr/>
-          <a:lstStyle/>
-          <a:p>
-            <a:endParaRPr lang="ru-RU"/>
-          </a:p>
-        </p:txBody>
-      </p:sp>
       <p:sp>
         <p:nvSpPr>
           <p:cNvPr id="5" name="Text 2"/>
@@ -12095,63 +11876,6 @@
           </a:p>
         </p:txBody>
       </p:sp>
-      <p:pic>
-        <p:nvPicPr>
-          <p:cNvPr id="7" name="Image 1" descr="preencoded.png"/>
-          <p:cNvPicPr>
-            <a:picLocks noChangeAspect="1"/>
-          </p:cNvPicPr>
-          <p:nvPr/>
-        </p:nvPicPr>
-        <p:blipFill>
-          <a:blip>
-            <a:extLst>
-              <a:ext uri="{96DAC541-7B7A-43D3-8B79-37D633B846F1}">
-                <asvg:svgBlip xmlns:asvg="http://schemas.microsoft.com/office/drawing/2016/SVG/main" r:embed="rId4"/>
-              </a:ext>
-            </a:extLst>
-          </a:blip>
-          <a:stretch>
-            <a:fillRect/>
-          </a:stretch>
-        </p:blipFill>
-        <p:spPr>
-          <a:xfrm>
-            <a:off x="4642842" y="1906042"/>
-            <a:ext cx="141759" cy="141759"/>
-          </a:xfrm>
-          <a:prstGeom prst="rect">
-            <a:avLst/>
-          </a:prstGeom>
-        </p:spPr>
-      </p:pic>
-      <p:sp>
-        <p:nvSpPr>
-          <p:cNvPr id="8" name="Shape 4"/>
-          <p:cNvSpPr/>
-          <p:nvPr/>
-        </p:nvSpPr>
-        <p:spPr>
-          <a:xfrm>
-            <a:off x="4642842" y="2110234"/>
-            <a:ext cx="4005039" cy="19050"/>
-          </a:xfrm>
-          <a:prstGeom prst="rect">
-            <a:avLst/>
-          </a:prstGeom>
-          <a:solidFill>
-            <a:srgbClr val="438951"/>
-          </a:solidFill>
-          <a:ln/>
-        </p:spPr>
-        <p:txBody>
-          <a:bodyPr/>
-          <a:lstStyle/>
-          <a:p>
-            <a:endParaRPr lang="ru-RU"/>
-          </a:p>
-        </p:txBody>
-      </p:sp>
       <p:sp>
         <p:nvSpPr>
           <p:cNvPr id="9" name="Text 5"/>
@@ -12238,63 +11962,6 @@
           </a:p>
         </p:txBody>
       </p:sp>
-      <p:pic>
-        <p:nvPicPr>
-          <p:cNvPr id="11" name="Image 2" descr="preencoded.png"/>
-          <p:cNvPicPr>
-            <a:picLocks noChangeAspect="1"/>
-          </p:cNvPicPr>
-          <p:nvPr/>
-        </p:nvPicPr>
-        <p:blipFill>
-          <a:blip>
-            <a:extLst>
-              <a:ext uri="{96DAC541-7B7A-43D3-8B79-37D633B846F1}">
-                <asvg:svgBlip xmlns:asvg="http://schemas.microsoft.com/office/drawing/2016/SVG/main" r:embed="rId5"/>
-              </a:ext>
-            </a:extLst>
-          </a:blip>
-          <a:stretch>
-            <a:fillRect/>
-          </a:stretch>
-        </p:blipFill>
-        <p:spPr>
-          <a:xfrm>
-            <a:off x="496119" y="3245048"/>
-            <a:ext cx="141759" cy="141759"/>
-          </a:xfrm>
-          <a:prstGeom prst="rect">
-            <a:avLst/>
-          </a:prstGeom>
-        </p:spPr>
-      </p:pic>
-      <p:sp>
-        <p:nvSpPr>
-          <p:cNvPr id="12" name="Shape 7"/>
-          <p:cNvSpPr/>
-          <p:nvPr/>
-        </p:nvSpPr>
-        <p:spPr>
-          <a:xfrm>
-            <a:off x="496119" y="3449241"/>
-            <a:ext cx="4004965" cy="19050"/>
-          </a:xfrm>
-          <a:prstGeom prst="rect">
-            <a:avLst/>
-          </a:prstGeom>
-          <a:solidFill>
-            <a:srgbClr val="438951"/>
-          </a:solidFill>
-          <a:ln/>
-        </p:spPr>
-        <p:txBody>
-          <a:bodyPr/>
-          <a:lstStyle/>
-          <a:p>
-            <a:endParaRPr lang="ru-RU"/>
-          </a:p>
-        </p:txBody>
-      </p:sp>
       <p:sp>
         <p:nvSpPr>
           <p:cNvPr id="13" name="Text 8"/>
@@ -12378,63 +12045,6 @@
               <a:t>Imom al-Buxoriy, Imom Termiziy kabi allomalar va ularning islom ilmining rivojiga qo'shgan hissasi.</a:t>
             </a:r>
             <a:endParaRPr lang="en-US" sz="1100" dirty="0"/>
-          </a:p>
-        </p:txBody>
-      </p:sp>
-      <p:pic>
-        <p:nvPicPr>
-          <p:cNvPr id="15" name="Image 3" descr="preencoded.png"/>
-          <p:cNvPicPr>
-            <a:picLocks noChangeAspect="1"/>
-          </p:cNvPicPr>
-          <p:nvPr/>
-        </p:nvPicPr>
-        <p:blipFill>
-          <a:blip>
-            <a:extLst>
-              <a:ext uri="{96DAC541-7B7A-43D3-8B79-37D633B846F1}">
-                <asvg:svgBlip xmlns:asvg="http://schemas.microsoft.com/office/drawing/2016/SVG/main" r:embed="rId6"/>
-              </a:ext>
-            </a:extLst>
-          </a:blip>
-          <a:stretch>
-            <a:fillRect/>
-          </a:stretch>
-        </p:blipFill>
-        <p:spPr>
-          <a:xfrm>
-            <a:off x="4642842" y="3245048"/>
-            <a:ext cx="141759" cy="141759"/>
-          </a:xfrm>
-          <a:prstGeom prst="rect">
-            <a:avLst/>
-          </a:prstGeom>
-        </p:spPr>
-      </p:pic>
-      <p:sp>
-        <p:nvSpPr>
-          <p:cNvPr id="16" name="Shape 10"/>
-          <p:cNvSpPr/>
-          <p:nvPr/>
-        </p:nvSpPr>
-        <p:spPr>
-          <a:xfrm>
-            <a:off x="4642842" y="3449241"/>
-            <a:ext cx="4005039" cy="19050"/>
-          </a:xfrm>
-          <a:prstGeom prst="rect">
-            <a:avLst/>
-          </a:prstGeom>
-          <a:solidFill>
-            <a:srgbClr val="438951"/>
-          </a:solidFill>
-          <a:ln/>
-        </p:spPr>
-        <p:txBody>
-          <a:bodyPr/>
-          <a:lstStyle/>
-          <a:p>
-            <a:endParaRPr lang="ru-RU"/>
           </a:p>
         </p:txBody>
       </p:sp>

</xml_diff>